<commit_message>
Deck and 3-min video: 14 sample listings built from public data (not customers), working on testnet, no real users yet; video 2:59
Co-Authored-By: Claude Opus 5.5 <noreply@anthropic.com>
</commit_message>
<xml_diff>
--- a/docs/pitch/BlockID-Business-Passport-3min.pptx
+++ b/docs/pitch/BlockID-Business-Passport-3min.pptx
@@ -1214,7 +1214,7 @@
           <a:p>
             <a:r>
               <a:rPr lang="en-US" dirty="0"/>
-              <a:t>[2:40–3:00] This is live today: thirteen businesses listed, thirty-eight share records on blockchain and eighty-seven billion dollars of fair value checked by people. Businesses pay a listing fee and a share-register subscription, plus a small fee per transfer and per dividend round. We're looking for pilot businesses, investor communities and licensed partners. Scan to try it, or scan to connect with me. Know the business you invest in. Thank you.</a:t>
+              <a:t>[2:40–3:00] The whole flow works today on testnet, with fourteen sample listings built from public information and forty-two share records on three blockchains. We have no real users yet: that is the next step. Businesses pay a listing fee and a share-register subscription, plus a small fee per transfer and per dividend round. We're looking for pilot businesses, investor communities and licensed partners. Scan to try it, or scan to connect with me. Know the business you invest in. Thank you.</a:t>
             </a:r>
             <a:endParaRPr lang="en-US" dirty="0"/>
           </a:p>
@@ -1929,7 +1929,7 @@
                 <a:ea typeface="Arial" pitchFamily="34" charset="-122"/>
                 <a:cs typeface="Arial" pitchFamily="34" charset="-120"/>
               </a:rPr>
-              <a:t>13</a:t>
+              <a:t>14</a:t>
             </a:r>
             <a:endParaRPr lang="en-US" sz="2200" dirty="0"/>
           </a:p>
@@ -1968,7 +1968,7 @@
                 <a:ea typeface="Calibri" pitchFamily="34" charset="-122"/>
                 <a:cs typeface="Calibri" pitchFamily="34" charset="-120"/>
               </a:rPr>
-              <a:t>businesses listed</a:t>
+              <a:t>sample listings (demo data)</a:t>
             </a:r>
             <a:endParaRPr lang="en-US" sz="1100" dirty="0"/>
           </a:p>
@@ -2034,7 +2034,7 @@
                 <a:ea typeface="Arial" pitchFamily="34" charset="-122"/>
                 <a:cs typeface="Arial" pitchFamily="34" charset="-120"/>
               </a:rPr>
-              <a:t>38</a:t>
+              <a:t>42</a:t>
             </a:r>
             <a:endParaRPr lang="en-US" sz="2200" dirty="0"/>
           </a:p>
@@ -2139,7 +2139,7 @@
                 <a:ea typeface="Arial" pitchFamily="34" charset="-122"/>
                 <a:cs typeface="Arial" pitchFamily="34" charset="-120"/>
               </a:rPr>
-              <a:t>A$87B</a:t>
+              <a:t>3</a:t>
             </a:r>
             <a:endParaRPr lang="en-US" sz="2200" dirty="0"/>
           </a:p>
@@ -2178,7 +2178,7 @@
                 <a:ea typeface="Calibri" pitchFamily="34" charset="-122"/>
                 <a:cs typeface="Calibri" pitchFamily="34" charset="-120"/>
               </a:rPr>
-              <a:t>fair value checked by people</a:t>
+              <a:t>blockchains, every record checkable</a:t>
             </a:r>
             <a:endParaRPr lang="en-US" sz="1100" dirty="0"/>
           </a:p>
@@ -2217,7 +2217,7 @@
                 <a:ea typeface="Calibri" pitchFamily="34" charset="-122"/>
                 <a:cs typeface="Calibri" pitchFamily="34" charset="-120"/>
               </a:rPr>
-              <a:t>Live today at eth.blockid.au</a:t>
+              <a:t>Working end to end on testnet at eth.blockid.au</a:t>
             </a:r>
             <a:endParaRPr lang="en-US" sz="1300" dirty="0"/>
           </a:p>
@@ -5095,7 +5095,7 @@
                 <a:ea typeface="Calibri" pitchFamily="34" charset="-122"/>
                 <a:cs typeface="Calibri" pitchFamily="34" charset="-120"/>
               </a:rPr>
-              <a:t>13 businesses listed · 38 share records on blockchain</a:t>
+              <a:t>14 sample listings · 42 share records on blockchain</a:t>
             </a:r>
             <a:endParaRPr lang="en-US" sz="1500" dirty="0"/>
           </a:p>
@@ -9659,7 +9659,7 @@
                 <a:ea typeface="Calibri" pitchFamily="34" charset="-122"/>
                 <a:cs typeface="Calibri" pitchFamily="34" charset="-120"/>
               </a:rPr>
-              <a:t>9 / 9   ·   LIVE TODAY · THE ASK</a:t>
+              <a:t>9 / 9   ·   WORKING TODAY · THE ASK</a:t>
             </a:r>
             <a:endParaRPr lang="en-US" sz="1150" dirty="0"/>
           </a:p>
@@ -9698,7 +9698,7 @@
                 <a:ea typeface="Arial" pitchFamily="34" charset="-122"/>
                 <a:cs typeface="Arial" pitchFamily="34" charset="-120"/>
               </a:rPr>
-              <a:t>Live today. Looking for pilot businesses and partners.</a:t>
+              <a:t>Working on testnet. Looking for our first pilot businesses.</a:t>
             </a:r>
             <a:endParaRPr lang="en-US" sz="3000" dirty="0"/>
           </a:p>
@@ -9764,7 +9764,7 @@
                 <a:ea typeface="Arial" pitchFamily="34" charset="-122"/>
                 <a:cs typeface="Arial" pitchFamily="34" charset="-120"/>
               </a:rPr>
-              <a:t>13</a:t>
+              <a:t>14</a:t>
             </a:r>
             <a:endParaRPr lang="en-US" sz="2800" dirty="0"/>
           </a:p>
@@ -9803,7 +9803,7 @@
                 <a:ea typeface="Calibri" pitchFamily="34" charset="-122"/>
                 <a:cs typeface="Calibri" pitchFamily="34" charset="-120"/>
               </a:rPr>
-              <a:t>businesses listed</a:t>
+              <a:t>sample listings built from public data</a:t>
             </a:r>
             <a:endParaRPr lang="en-US" sz="1150" dirty="0"/>
           </a:p>
@@ -9869,7 +9869,7 @@
                 <a:ea typeface="Arial" pitchFamily="34" charset="-122"/>
                 <a:cs typeface="Arial" pitchFamily="34" charset="-120"/>
               </a:rPr>
-              <a:t>38</a:t>
+              <a:t>42</a:t>
             </a:r>
             <a:endParaRPr lang="en-US" sz="2800" dirty="0"/>
           </a:p>
@@ -9974,7 +9974,7 @@
                 <a:ea typeface="Arial" pitchFamily="34" charset="-122"/>
                 <a:cs typeface="Arial" pitchFamily="34" charset="-120"/>
               </a:rPr>
-              <a:t>A$87B</a:t>
+              <a:t>3</a:t>
             </a:r>
             <a:endParaRPr lang="en-US" sz="2800" dirty="0"/>
           </a:p>
@@ -10013,7 +10013,7 @@
                 <a:ea typeface="Calibri" pitchFamily="34" charset="-122"/>
                 <a:cs typeface="Calibri" pitchFamily="34" charset="-120"/>
               </a:rPr>
-              <a:t>fair value checked by people</a:t>
+              <a:t>blockchains, every record checkable</a:t>
             </a:r>
             <a:endParaRPr lang="en-US" sz="1150" dirty="0"/>
           </a:p>
@@ -10079,7 +10079,7 @@
                 <a:ea typeface="Arial" pitchFamily="34" charset="-122"/>
                 <a:cs typeface="Arial" pitchFamily="34" charset="-120"/>
               </a:rPr>
-              <a:t>3</a:t>
+              <a:t>Next</a:t>
             </a:r>
             <a:endParaRPr lang="en-US" sz="2800" dirty="0"/>
           </a:p>
@@ -10118,7 +10118,7 @@
                 <a:ea typeface="Calibri" pitchFamily="34" charset="-122"/>
                 <a:cs typeface="Calibri" pitchFamily="34" charset="-120"/>
               </a:rPr>
-              <a:t>blockchains, every record checkable</a:t>
+              <a:t>first real pilots in AU · VN</a:t>
             </a:r>
             <a:endParaRPr lang="en-US" sz="1150" dirty="0"/>
           </a:p>

</xml_diff>

<commit_message>
Human-first pitch: no internal tagline or AI jargon in deck, video, demo page; slide 13 'Join us' invites Ethereum investors and L1/L2 teams to run BlockID on their chain; full-frame live recordings with message overlay (3-min 2:58, full 5:15); demo page generator
Co-Authored-By: Claude Opus 5.5 <noreply@anthropic.com>
</commit_message>
<xml_diff>
--- a/docs/pitch/BlockID-Business-Passport-3min.pptx
+++ b/docs/pitch/BlockID-Business-Passport-3min.pptx
@@ -1305,7 +1305,7 @@
           <a:p>
             <a:r>
               <a:rPr lang="en-US" dirty="0"/>
-              <a:t>[1:57–2:15] This also prepares for tokenised assets. Tokenised real-world assets on-chain grew from about seven to thirty-nine billion dollars in nineteen months (rwa.xyz), and Citi expects five and a half trillion by 2030. New rules in Europe, Vietnam and Australia require proper custody. In BlockID, keys sit only in an isolated issuer, every holder is verified, every record is anchored on three chains, and a licensed custodian can plug in.</a:t>
+              <a:t>[1:57–2:15] This also prepares for tokenised assets. Tokenised real-world assets on-chain grew from about seven to thirty-nine billion dollars in nineteen months (rwa.xyz), and Citi expects five and a half trillion by 2030. New rules in Europe, Vietnam and Australia require proper custody. In BlockID, keys sit in one locked-down signing service, every holder is verified, every record is on three chains, and a licensed custodian can plug in.</a:t>
             </a:r>
             <a:endParaRPr lang="en-US" dirty="0"/>
           </a:p>
@@ -1393,7 +1393,7 @@
           <a:p>
             <a:r>
               <a:rPr lang="en-US" dirty="0"/>
-              <a:t>[2:15–2:30] Under the hood, only approved actions reach the chain. AI runs with no keys, an admin wallet signs one approval, and only then does the isolated issuer act. Our AgentProvenance contract on HashKey Chain records who proposed and who approved. Agents propose. Humans approve. Chains prove.</a:t>
+              <a:t>[2:15–2:30] How it works. Research tools draft, but they never touch keys. A named person reviews and approves every valuation, new share and dividend, and no one can approve their own request. Only then is it written to the chain, and anyone can check the record. It runs on any EVM chain, layer 1 or layer 2: today BlockID Chain, Ethereum and HashKey Chain.</a:t>
             </a:r>
             <a:endParaRPr lang="en-US" dirty="0"/>
           </a:p>
@@ -1569,7 +1569,7 @@
           <a:p>
             <a:r>
               <a:rPr lang="en-US" dirty="0"/>
-              <a:t>[2:45–3:00] The whole flow works on testnet today: fourteen sample listings and forty-two token contracts on three chains, with no real users yet. Next: pilot businesses in Australia and Vietnam, investor communities and licensed custody partners. Businesses pay a listing fee, a register subscription and small transfer and dividend fees. Try it at eth.blockid.au. Thank you.</a:t>
+              <a:t>[2:45–3:00] Everything you saw runs today on testnet, across BlockID Chain, Ethereum and HashKey Chain. We invite Ethereum investors to back our first pilots in Australia and Vietnam, and layer one and layer two teams to run BlockID on their chain as a real-world-asset case. Licensed partners can bring custody and offerings. Know the business you invest in. Try it at eth.blockid.au.</a:t>
             </a:r>
             <a:endParaRPr lang="en-US" dirty="0"/>
           </a:p>
@@ -1921,7 +1921,7 @@
           <a:p>
             <a:r>
               <a:rPr lang="en-US" dirty="0"/>
-              <a:t>[0:52–1:05] Understand it. Paste a website and get a plain report in minutes: a grade from A to E and a low, mid and high value. AI agents do the research but hold no keys; every figure links to its source, and a person approves it.</a:t>
+              <a:t>[0:52–1:05] Understand it. Paste a website and get a plain report in minutes: a grade from A to E and a low, mid and high value. Independent research does the legwork, every figure links to its source, and a person approves it before anyone sees it.</a:t>
             </a:r>
             <a:endParaRPr lang="en-US" dirty="0"/>
           </a:p>
@@ -2798,7 +2798,7 @@
                 <a:ea typeface="Calibri" pitchFamily="34" charset="-122"/>
                 <a:cs typeface="Calibri" pitchFamily="34" charset="-120"/>
               </a:rPr>
-              <a:t>BlockID Business Passport gives every shareholder, large or small, a live view of the business they own: AI-analysed, human-approved updates and valuations, an on-chain share register as proof of ownership, and dividends paid straight to their wallet.</a:t>
+              <a:t>BlockID Business Passport gives every shareholder, large or small, a live view of the business they own: updates and valuations checked and approved by people, a share register on blockchain as proof of ownership, and dividends paid straight to their wallet.</a:t>
             </a:r>
             <a:endParaRPr lang="en-US" sz="1700" dirty="0"/>
           </a:p>
@@ -3193,7 +3193,7 @@
                 <a:ea typeface="Calibri" pitchFamily="34" charset="-122"/>
                 <a:cs typeface="Calibri" pitchFamily="34" charset="-120"/>
               </a:rPr>
-              <a:t>sample listings (demo data)</a:t>
+              <a:t>sample listings, live on testnet</a:t>
             </a:r>
             <a:endParaRPr lang="en-US" sz="1100" dirty="0"/>
           </a:p>
@@ -3403,7 +3403,7 @@
                 <a:ea typeface="Calibri" pitchFamily="34" charset="-122"/>
                 <a:cs typeface="Calibri" pitchFamily="34" charset="-120"/>
               </a:rPr>
-              <a:t>blockchains, every record checkable</a:t>
+              <a:t>chains, every record checkable</a:t>
             </a:r>
             <a:endParaRPr lang="en-US" sz="1100" dirty="0"/>
           </a:p>
@@ -3412,45 +3412,6 @@
       <p:sp>
         <p:nvSpPr>
           <p:cNvPr id="25" name="Text 21"/>
-          <p:cNvSpPr txBox="1"/>
-          <p:nvPr/>
-        </p:nvSpPr>
-        <p:spPr>
-          <a:xfrm>
-            <a:off x="6035040" y="6257925"/>
-            <a:ext cx="5715000" cy="320040"/>
-          </a:xfrm>
-          <a:prstGeom prst="rect">
-            <a:avLst/>
-          </a:prstGeom>
-          <a:noFill/>
-          <a:ln/>
-        </p:spPr>
-        <p:txBody>
-          <a:bodyPr wrap="square" lIns="0" tIns="0" rIns="0" bIns="0" rtlCol="0" anchor="ctr"/>
-          <a:lstStyle/>
-          <a:p>
-            <a:pPr algn="ctr" indent="0" marL="0">
-              <a:buNone/>
-            </a:pPr>
-            <a:r>
-              <a:rPr lang="en-US" sz="1300" i="1" dirty="0">
-                <a:solidFill>
-                  <a:srgbClr val="7E948F"/>
-                </a:solidFill>
-                <a:latin typeface="Calibri" pitchFamily="34" charset="0"/>
-                <a:ea typeface="Calibri" pitchFamily="34" charset="-122"/>
-                <a:cs typeface="Calibri" pitchFamily="34" charset="-120"/>
-              </a:rPr>
-              <a:t>Working end to end on testnet at eth.blockid.au</a:t>
-            </a:r>
-            <a:endParaRPr lang="en-US" sz="1300" dirty="0"/>
-          </a:p>
-        </p:txBody>
-      </p:sp>
-      <p:sp>
-        <p:nvSpPr>
-          <p:cNvPr id="26" name="Text 22"/>
           <p:cNvSpPr txBox="1"/>
           <p:nvPr/>
         </p:nvSpPr>
@@ -4090,7 +4051,7 @@
                 <a:ea typeface="Calibri" pitchFamily="34" charset="-122"/>
                 <a:cs typeface="Calibri" pitchFamily="34" charset="-120"/>
               </a:rPr>
-              <a:t>Keys only in an isolated issuer · every holder verified (KYC) · register anchored on 3 chains · a licensed custodian plugs in, investors keep proof</a:t>
+              <a:t>Keys sit in one locked-down signing service, never with the research tools · every holder verified (KYC) · records on 3 chains · a licensed custodian plugs in, investors keep the proof</a:t>
             </a:r>
             <a:endParaRPr lang="en-US" sz="1250" dirty="0"/>
           </a:p>
@@ -4200,7 +4161,7 @@
                 <a:ea typeface="Calibri" pitchFamily="34" charset="-122"/>
                 <a:cs typeface="Calibri" pitchFamily="34" charset="-120"/>
               </a:rPr>
-              <a:t>11 / 13   ·   HOW IT'S BUILT</a:t>
+              <a:t>11 / 13   ·   HOW IT WORKS</a:t>
             </a:r>
             <a:endParaRPr lang="en-US" sz="1150" dirty="0"/>
           </a:p>
@@ -4239,7 +4200,7 @@
                 <a:ea typeface="Arial" pitchFamily="34" charset="-122"/>
                 <a:cs typeface="Arial" pitchFamily="34" charset="-120"/>
               </a:rPr>
-              <a:t>Agents propose. Humans approve. Chains prove.</a:t>
+              <a:t>People decide. Every step is on the record.</a:t>
             </a:r>
             <a:endParaRPr lang="en-US" sz="3000" dirty="0"/>
           </a:p>
@@ -4439,7 +4400,7 @@
                 <a:ea typeface="Calibri" pitchFamily="34" charset="-122"/>
                 <a:cs typeface="Calibri" pitchFamily="34" charset="-120"/>
               </a:rPr>
-              <a:t>eth.blockid.au/admin  ·  a person approves</a:t>
+              <a:t>eth.blockid.au/admin  ·  every step waits for a person</a:t>
             </a:r>
             <a:endParaRPr lang="en-US" sz="850" dirty="0"/>
           </a:p>
@@ -4753,7 +4714,7 @@
                 <a:ea typeface="Arial" pitchFamily="34" charset="-122"/>
                 <a:cs typeface="Arial" pitchFamily="34" charset="-120"/>
               </a:rPr>
-              <a:t>AI agents propose</a:t>
+              <a:t>Research drafts</a:t>
             </a:r>
             <a:endParaRPr lang="en-US" sz="1400" dirty="0"/>
           </a:p>
@@ -4792,7 +4753,7 @@
                 <a:ea typeface="Calibri" pitchFamily="34" charset="-122"/>
                 <a:cs typeface="Calibri" pitchFamily="34" charset="-120"/>
               </a:rPr>
-              <a:t>research and value; no keys, no network path to keys</a:t>
+              <a:t>public sources gathered and checked; drafts only, no access to keys</a:t>
             </a:r>
             <a:endParaRPr lang="en-US" sz="1050" dirty="0"/>
           </a:p>
@@ -4936,7 +4897,7 @@
                 <a:ea typeface="Calibri" pitchFamily="34" charset="-122"/>
                 <a:cs typeface="Calibri" pitchFamily="34" charset="-120"/>
               </a:rPr>
-              <a:t>admin wallet signs one approval, four-eyes rule on chain</a:t>
+              <a:t>a named reviewer signs; no one can approve their own request</a:t>
             </a:r>
             <a:endParaRPr lang="en-US" sz="1050" dirty="0"/>
           </a:p>
@@ -5041,7 +5002,7 @@
                 <a:ea typeface="Arial" pitchFamily="34" charset="-122"/>
                 <a:cs typeface="Arial" pitchFamily="34" charset="-120"/>
               </a:rPr>
-              <a:t>Isolated issuer acts</a:t>
+              <a:t>Recorded on chain</a:t>
             </a:r>
             <a:endParaRPr lang="en-US" sz="1400" dirty="0"/>
           </a:p>
@@ -5080,7 +5041,7 @@
                 <a:ea typeface="Calibri" pitchFamily="34" charset="-122"/>
                 <a:cs typeface="Calibri" pitchFamily="34" charset="-120"/>
               </a:rPr>
-              <a:t>only key holder; writes BlockID Chain, mirrors Ethereum + HashKey</a:t>
+              <a:t>any EVM chain, L1 or L2; live on BlockID Chain, Ethereum and HashKey</a:t>
             </a:r>
             <a:endParaRPr lang="en-US" sz="1050" dirty="0"/>
           </a:p>
@@ -6545,7 +6506,7 @@
                 <a:ea typeface="Calibri" pitchFamily="34" charset="-122"/>
                 <a:cs typeface="Calibri" pitchFamily="34" charset="-120"/>
               </a:rPr>
-              <a:t>Smart contracts, AI agents, key-holding issuer, web app, 3 chains</a:t>
+              <a:t>Smart contracts, research tools, secure signing service, web app, 3 chains</a:t>
             </a:r>
             <a:endParaRPr lang="en-US" sz="1150" dirty="0"/>
           </a:p>
@@ -6655,7 +6616,7 @@
                 <a:ea typeface="Calibri" pitchFamily="34" charset="-122"/>
                 <a:cs typeface="Calibri" pitchFamily="34" charset="-120"/>
               </a:rPr>
-              <a:t>13 / 13   ·   WORKING TODAY · THE ASK</a:t>
+              <a:t>13 / 13   ·   JOIN US</a:t>
             </a:r>
             <a:endParaRPr lang="en-US" sz="1150" dirty="0"/>
           </a:p>
@@ -6694,7 +6655,7 @@
                 <a:ea typeface="Arial" pitchFamily="34" charset="-122"/>
                 <a:cs typeface="Arial" pitchFamily="34" charset="-120"/>
               </a:rPr>
-              <a:t>Working on testnet. Looking for our first pilot businesses.</a:t>
+              <a:t>A real app, ready to run on your chain.</a:t>
             </a:r>
             <a:endParaRPr lang="en-US" sz="3000" dirty="0"/>
           </a:p>
@@ -6709,11 +6670,11 @@
         <p:spPr>
           <a:xfrm>
             <a:off x="502920" y="1600200"/>
-            <a:ext cx="1737360" cy="1325880"/>
+            <a:ext cx="2350008" cy="1097280"/>
           </a:xfrm>
           <a:prstGeom prst="roundRect">
             <a:avLst>
-              <a:gd name="adj" fmla="val 8276"/>
+              <a:gd name="adj" fmla="val 10000"/>
             </a:avLst>
           </a:prstGeom>
           <a:solidFill>
@@ -6735,8 +6696,8 @@
         </p:nvSpPr>
         <p:spPr>
           <a:xfrm>
-            <a:off x="640080" y="1673352"/>
-            <a:ext cx="1508760" cy="640080"/>
+            <a:off x="667512" y="1645920"/>
+            <a:ext cx="2011680" cy="548640"/>
           </a:xfrm>
           <a:prstGeom prst="rect">
             <a:avLst/>
@@ -6752,7 +6713,7 @@
               <a:buNone/>
             </a:pPr>
             <a:r>
-              <a:rPr lang="en-US" sz="2800" b="1" dirty="0">
+              <a:rPr lang="en-US" sz="2600" b="1" dirty="0">
                 <a:solidFill>
                   <a:srgbClr val="22A07F"/>
                 </a:solidFill>
@@ -6762,7 +6723,7 @@
               </a:rPr>
               <a:t>14</a:t>
             </a:r>
-            <a:endParaRPr lang="en-US" sz="2800" dirty="0"/>
+            <a:endParaRPr lang="en-US" sz="2600" dirty="0"/>
           </a:p>
         </p:txBody>
       </p:sp>
@@ -6774,8 +6735,8 @@
         </p:nvSpPr>
         <p:spPr>
           <a:xfrm>
-            <a:off x="640080" y="2331720"/>
-            <a:ext cx="1508760" cy="548640"/>
+            <a:off x="667512" y="2194560"/>
+            <a:ext cx="2103120" cy="457200"/>
           </a:xfrm>
           <a:prstGeom prst="rect">
             <a:avLst/>
@@ -6799,7 +6760,7 @@
                 <a:ea typeface="Calibri" pitchFamily="34" charset="-122"/>
                 <a:cs typeface="Calibri" pitchFamily="34" charset="-120"/>
               </a:rPr>
-              <a:t>sample listings built from public data</a:t>
+              <a:t>sample listings live on testnet</a:t>
             </a:r>
             <a:endParaRPr lang="en-US" sz="1150" dirty="0"/>
           </a:p>
@@ -6813,12 +6774,12 @@
         </p:nvSpPr>
         <p:spPr>
           <a:xfrm>
-            <a:off x="2377440" y="1600200"/>
-            <a:ext cx="1737360" cy="1325880"/>
+            <a:off x="2990088" y="1600200"/>
+            <a:ext cx="2350008" cy="1097280"/>
           </a:xfrm>
           <a:prstGeom prst="roundRect">
             <a:avLst>
-              <a:gd name="adj" fmla="val 8276"/>
+              <a:gd name="adj" fmla="val 10000"/>
             </a:avLst>
           </a:prstGeom>
           <a:solidFill>
@@ -6840,8 +6801,8 @@
         </p:nvSpPr>
         <p:spPr>
           <a:xfrm>
-            <a:off x="2514600" y="1673352"/>
-            <a:ext cx="1508760" cy="640080"/>
+            <a:off x="3154680" y="1645920"/>
+            <a:ext cx="2011680" cy="548640"/>
           </a:xfrm>
           <a:prstGeom prst="rect">
             <a:avLst/>
@@ -6857,7 +6818,7 @@
               <a:buNone/>
             </a:pPr>
             <a:r>
-              <a:rPr lang="en-US" sz="2800" b="1" dirty="0">
+              <a:rPr lang="en-US" sz="2600" b="1" dirty="0">
                 <a:solidFill>
                   <a:srgbClr val="E3A83A"/>
                 </a:solidFill>
@@ -6867,7 +6828,7 @@
               </a:rPr>
               <a:t>42</a:t>
             </a:r>
-            <a:endParaRPr lang="en-US" sz="2800" dirty="0"/>
+            <a:endParaRPr lang="en-US" sz="2600" dirty="0"/>
           </a:p>
         </p:txBody>
       </p:sp>
@@ -6879,8 +6840,8 @@
         </p:nvSpPr>
         <p:spPr>
           <a:xfrm>
-            <a:off x="2514600" y="2331720"/>
-            <a:ext cx="1508760" cy="548640"/>
+            <a:off x="3154680" y="2194560"/>
+            <a:ext cx="2103120" cy="457200"/>
           </a:xfrm>
           <a:prstGeom prst="rect">
             <a:avLst/>
@@ -6904,7 +6865,7 @@
                 <a:ea typeface="Calibri" pitchFamily="34" charset="-122"/>
                 <a:cs typeface="Calibri" pitchFamily="34" charset="-120"/>
               </a:rPr>
-              <a:t>share records on blockchain</a:t>
+              <a:t>share-token contracts</a:t>
             </a:r>
             <a:endParaRPr lang="en-US" sz="1150" dirty="0"/>
           </a:p>
@@ -6918,12 +6879,12 @@
         </p:nvSpPr>
         <p:spPr>
           <a:xfrm>
-            <a:off x="4251960" y="1600200"/>
-            <a:ext cx="1737360" cy="1325880"/>
+            <a:off x="5477256" y="1600200"/>
+            <a:ext cx="2350008" cy="1097280"/>
           </a:xfrm>
           <a:prstGeom prst="roundRect">
             <a:avLst>
-              <a:gd name="adj" fmla="val 8276"/>
+              <a:gd name="adj" fmla="val 10000"/>
             </a:avLst>
           </a:prstGeom>
           <a:solidFill>
@@ -6945,8 +6906,8 @@
         </p:nvSpPr>
         <p:spPr>
           <a:xfrm>
-            <a:off x="4389120" y="1673352"/>
-            <a:ext cx="1508760" cy="640080"/>
+            <a:off x="5641848" y="1645920"/>
+            <a:ext cx="2011680" cy="548640"/>
           </a:xfrm>
           <a:prstGeom prst="rect">
             <a:avLst/>
@@ -6962,7 +6923,7 @@
               <a:buNone/>
             </a:pPr>
             <a:r>
-              <a:rPr lang="en-US" sz="2800" b="1" dirty="0">
+              <a:rPr lang="en-US" sz="2600" b="1" dirty="0">
                 <a:solidFill>
                   <a:srgbClr val="22A07F"/>
                 </a:solidFill>
@@ -6972,7 +6933,7 @@
               </a:rPr>
               <a:t>3</a:t>
             </a:r>
-            <a:endParaRPr lang="en-US" sz="2800" dirty="0"/>
+            <a:endParaRPr lang="en-US" sz="2600" dirty="0"/>
           </a:p>
         </p:txBody>
       </p:sp>
@@ -6984,8 +6945,8 @@
         </p:nvSpPr>
         <p:spPr>
           <a:xfrm>
-            <a:off x="4389120" y="2331720"/>
-            <a:ext cx="1508760" cy="548640"/>
+            <a:off x="5641848" y="2194560"/>
+            <a:ext cx="2103120" cy="457200"/>
           </a:xfrm>
           <a:prstGeom prst="rect">
             <a:avLst/>
@@ -7009,7 +6970,7 @@
                 <a:ea typeface="Calibri" pitchFamily="34" charset="-122"/>
                 <a:cs typeface="Calibri" pitchFamily="34" charset="-120"/>
               </a:rPr>
-              <a:t>blockchains, every record checkable</a:t>
+              <a:t>chains: BlockID L1, Ethereum, HashKey L2</a:t>
             </a:r>
             <a:endParaRPr lang="en-US" sz="1150" dirty="0"/>
           </a:p>
@@ -7023,12 +6984,12 @@
         </p:nvSpPr>
         <p:spPr>
           <a:xfrm>
-            <a:off x="6126480" y="1600200"/>
-            <a:ext cx="1737360" cy="1325880"/>
+            <a:off x="502920" y="2880360"/>
+            <a:ext cx="7269480" cy="960120"/>
           </a:xfrm>
           <a:prstGeom prst="roundRect">
             <a:avLst>
-              <a:gd name="adj" fmla="val 8276"/>
+              <a:gd name="adj" fmla="val 11429"/>
             </a:avLst>
           </a:prstGeom>
           <a:solidFill>
@@ -7036,7 +6997,7 @@
           </a:solidFill>
           <a:ln w="12700">
             <a:solidFill>
-              <a:srgbClr val="25403A"/>
+              <a:srgbClr val="22A07F"/>
             </a:solidFill>
             <a:prstDash val="solid"/>
           </a:ln>
@@ -7050,8 +7011,8 @@
         </p:nvSpPr>
         <p:spPr>
           <a:xfrm>
-            <a:off x="6263640" y="1673352"/>
-            <a:ext cx="1508760" cy="640080"/>
+            <a:off x="731520" y="2953512"/>
+            <a:ext cx="6858000" cy="365760"/>
           </a:xfrm>
           <a:prstGeom prst="rect">
             <a:avLst/>
@@ -7067,17 +7028,17 @@
               <a:buNone/>
             </a:pPr>
             <a:r>
-              <a:rPr lang="en-US" sz="2800" b="1" dirty="0">
-                <a:solidFill>
-                  <a:srgbClr val="E3A83A"/>
+              <a:rPr lang="en-US" sz="1600" b="1" dirty="0">
+                <a:solidFill>
+                  <a:srgbClr val="22A07F"/>
                 </a:solidFill>
                 <a:latin typeface="Arial" pitchFamily="34" charset="0"/>
                 <a:ea typeface="Arial" pitchFamily="34" charset="-122"/>
                 <a:cs typeface="Arial" pitchFamily="34" charset="-120"/>
               </a:rPr>
-              <a:t>Next</a:t>
-            </a:r>
-            <a:endParaRPr lang="en-US" sz="2800" dirty="0"/>
+              <a:t>Ethereum investors</a:t>
+            </a:r>
+            <a:endParaRPr lang="en-US" sz="1600" dirty="0"/>
           </a:p>
         </p:txBody>
       </p:sp>
@@ -7089,8 +7050,8 @@
         </p:nvSpPr>
         <p:spPr>
           <a:xfrm>
-            <a:off x="6263640" y="2331720"/>
-            <a:ext cx="1508760" cy="548640"/>
+            <a:off x="731520" y="3319272"/>
+            <a:ext cx="6858000" cy="475488"/>
           </a:xfrm>
           <a:prstGeom prst="rect">
             <a:avLst/>
@@ -7106,17 +7067,17 @@
               <a:buNone/>
             </a:pPr>
             <a:r>
-              <a:rPr lang="en-US" sz="1150" dirty="0">
-                <a:solidFill>
-                  <a:srgbClr val="A9BDB7"/>
+              <a:rPr lang="en-US" sz="1250" dirty="0">
+                <a:solidFill>
+                  <a:srgbClr val="F2F7F5"/>
                 </a:solidFill>
                 <a:latin typeface="Calibri" pitchFamily="34" charset="0"/>
                 <a:ea typeface="Calibri" pitchFamily="34" charset="-122"/>
                 <a:cs typeface="Calibri" pitchFamily="34" charset="-120"/>
               </a:rPr>
-              <a:t>first real pilots in AU · VN</a:t>
-            </a:r>
-            <a:endParaRPr lang="en-US" sz="1150" dirty="0"/>
+              <a:t>Back our first pilots in Australia and Vietnam: real businesses, real shareholders, on Ethereum rails.</a:t>
+            </a:r>
+            <a:endParaRPr lang="en-US" sz="1250" dirty="0"/>
           </a:p>
         </p:txBody>
       </p:sp>
@@ -7128,12 +7089,12 @@
         </p:nvSpPr>
         <p:spPr>
           <a:xfrm>
-            <a:off x="502920" y="3108960"/>
-            <a:ext cx="3611880" cy="3063240"/>
+            <a:off x="502920" y="3977640"/>
+            <a:ext cx="7269480" cy="960120"/>
           </a:xfrm>
           <a:prstGeom prst="roundRect">
             <a:avLst>
-              <a:gd name="adj" fmla="val 3582"/>
+              <a:gd name="adj" fmla="val 11429"/>
             </a:avLst>
           </a:prstGeom>
           <a:solidFill>
@@ -7141,7 +7102,7 @@
           </a:solidFill>
           <a:ln w="12700">
             <a:solidFill>
-              <a:srgbClr val="25403A"/>
+              <a:srgbClr val="E3A83A"/>
             </a:solidFill>
             <a:prstDash val="solid"/>
           </a:ln>
@@ -7155,8 +7116,8 @@
         </p:nvSpPr>
         <p:spPr>
           <a:xfrm>
-            <a:off x="731520" y="3246120"/>
-            <a:ext cx="3200400" cy="274320"/>
+            <a:off x="731520" y="4050792"/>
+            <a:ext cx="6858000" cy="365760"/>
           </a:xfrm>
           <a:prstGeom prst="rect">
             <a:avLst/>
@@ -7172,71 +7133,151 @@
               <a:buNone/>
             </a:pPr>
             <a:r>
-              <a:rPr lang="en-US" sz="1150" b="1" spc="300" kern="0" dirty="0">
+              <a:rPr lang="en-US" sz="1600" b="1" dirty="0">
                 <a:solidFill>
                   <a:srgbClr val="E3A83A"/>
+                </a:solidFill>
+                <a:latin typeface="Arial" pitchFamily="34" charset="0"/>
+                <a:ea typeface="Arial" pitchFamily="34" charset="-122"/>
+                <a:cs typeface="Arial" pitchFamily="34" charset="-120"/>
+              </a:rPr>
+              <a:t>L1 and L2 teams</a:t>
+            </a:r>
+            <a:endParaRPr lang="en-US" sz="1600" dirty="0"/>
+          </a:p>
+        </p:txBody>
+      </p:sp>
+      <p:sp>
+        <p:nvSpPr>
+          <p:cNvPr id="18" name="Text 16"/>
+          <p:cNvSpPr txBox="1"/>
+          <p:nvPr/>
+        </p:nvSpPr>
+        <p:spPr>
+          <a:xfrm>
+            <a:off x="731520" y="4416552"/>
+            <a:ext cx="6858000" cy="475488"/>
+          </a:xfrm>
+          <a:prstGeom prst="rect">
+            <a:avLst/>
+          </a:prstGeom>
+          <a:noFill/>
+          <a:ln/>
+        </p:spPr>
+        <p:txBody>
+          <a:bodyPr wrap="square" lIns="0" tIns="0" rIns="0" bIns="0" rtlCol="0" anchor="ctr"/>
+          <a:lstStyle/>
+          <a:p>
+            <a:pPr indent="0" marL="0">
+              <a:buNone/>
+            </a:pPr>
+            <a:r>
+              <a:rPr lang="en-US" sz="1250" dirty="0">
+                <a:solidFill>
+                  <a:srgbClr val="F2F7F5"/>
                 </a:solidFill>
                 <a:latin typeface="Calibri" pitchFamily="34" charset="0"/>
                 <a:ea typeface="Calibri" pitchFamily="34" charset="-122"/>
                 <a:cs typeface="Calibri" pitchFamily="34" charset="-120"/>
               </a:rPr>
-              <a:t>WHO PAYS</a:t>
-            </a:r>
-            <a:endParaRPr lang="en-US" sz="1150" dirty="0"/>
-          </a:p>
-        </p:txBody>
-      </p:sp>
-      <p:sp>
-        <p:nvSpPr>
-          <p:cNvPr id="18" name="Shape 16"/>
+              <a:t>Run BlockID on your chain as a real-world-asset case: share registers, updates, dividends and checks. Any EVM chain.</a:t>
+            </a:r>
+            <a:endParaRPr lang="en-US" sz="1250" dirty="0"/>
+          </a:p>
+        </p:txBody>
+      </p:sp>
+      <p:sp>
+        <p:nvSpPr>
+          <p:cNvPr id="19" name="Shape 17"/>
           <p:cNvSpPr/>
           <p:nvPr/>
         </p:nvSpPr>
         <p:spPr>
           <a:xfrm>
-            <a:off x="731520" y="3703320"/>
-            <a:ext cx="146304" cy="146304"/>
-          </a:xfrm>
-          <a:prstGeom prst="ellipse">
-            <a:avLst/>
-          </a:prstGeom>
-          <a:solidFill>
-            <a:srgbClr val="E3A83A"/>
+            <a:off x="502920" y="5074920"/>
+            <a:ext cx="7269480" cy="960120"/>
+          </a:xfrm>
+          <a:prstGeom prst="roundRect">
+            <a:avLst>
+              <a:gd name="adj" fmla="val 11429"/>
+            </a:avLst>
+          </a:prstGeom>
+          <a:solidFill>
+            <a:srgbClr val="12201D"/>
           </a:solidFill>
           <a:ln w="12700">
             <a:solidFill>
-              <a:srgbClr val="E3A83A"/>
-            </a:solidFill>
-            <a:prstDash val="solid"/>
-          </a:ln>
-        </p:spPr>
-      </p:sp>
-      <p:sp>
-        <p:nvSpPr>
-          <p:cNvPr id="19" name="Text 17"/>
-          <p:cNvSpPr txBox="1"/>
-          <p:nvPr/>
-        </p:nvSpPr>
-        <p:spPr>
-          <a:xfrm>
-            <a:off x="1024128" y="3611880"/>
-            <a:ext cx="2953512" cy="640080"/>
-          </a:xfrm>
-          <a:prstGeom prst="rect">
-            <a:avLst/>
-          </a:prstGeom>
-          <a:noFill/>
-          <a:ln/>
-        </p:spPr>
-        <p:txBody>
-          <a:bodyPr wrap="square" lIns="0" tIns="0" rIns="0" bIns="0" rtlCol="0" anchor="t"/>
-          <a:lstStyle/>
-          <a:p>
-            <a:pPr indent="0" marL="0">
-              <a:buNone/>
-            </a:pPr>
-            <a:r>
-              <a:rPr lang="en-US" sz="1350" dirty="0">
+              <a:srgbClr val="9B7BD4"/>
+            </a:solidFill>
+            <a:prstDash val="solid"/>
+          </a:ln>
+        </p:spPr>
+      </p:sp>
+      <p:sp>
+        <p:nvSpPr>
+          <p:cNvPr id="20" name="Text 18"/>
+          <p:cNvSpPr txBox="1"/>
+          <p:nvPr/>
+        </p:nvSpPr>
+        <p:spPr>
+          <a:xfrm>
+            <a:off x="731520" y="5148072"/>
+            <a:ext cx="6858000" cy="365760"/>
+          </a:xfrm>
+          <a:prstGeom prst="rect">
+            <a:avLst/>
+          </a:prstGeom>
+          <a:noFill/>
+          <a:ln/>
+        </p:spPr>
+        <p:txBody>
+          <a:bodyPr wrap="square" lIns="0" tIns="0" rIns="0" bIns="0" rtlCol="0" anchor="ctr"/>
+          <a:lstStyle/>
+          <a:p>
+            <a:pPr indent="0" marL="0">
+              <a:buNone/>
+            </a:pPr>
+            <a:r>
+              <a:rPr lang="en-US" sz="1600" b="1" dirty="0">
+                <a:solidFill>
+                  <a:srgbClr val="9B7BD4"/>
+                </a:solidFill>
+                <a:latin typeface="Arial" pitchFamily="34" charset="0"/>
+                <a:ea typeface="Arial" pitchFamily="34" charset="-122"/>
+                <a:cs typeface="Arial" pitchFamily="34" charset="-120"/>
+              </a:rPr>
+              <a:t>Licensed partners</a:t>
+            </a:r>
+            <a:endParaRPr lang="en-US" sz="1600" dirty="0"/>
+          </a:p>
+        </p:txBody>
+      </p:sp>
+      <p:sp>
+        <p:nvSpPr>
+          <p:cNvPr id="21" name="Text 19"/>
+          <p:cNvSpPr txBox="1"/>
+          <p:nvPr/>
+        </p:nvSpPr>
+        <p:spPr>
+          <a:xfrm>
+            <a:off x="731520" y="5513832"/>
+            <a:ext cx="6858000" cy="475488"/>
+          </a:xfrm>
+          <a:prstGeom prst="rect">
+            <a:avLst/>
+          </a:prstGeom>
+          <a:noFill/>
+          <a:ln/>
+        </p:spPr>
+        <p:txBody>
+          <a:bodyPr wrap="square" lIns="0" tIns="0" rIns="0" bIns="0" rtlCol="0" anchor="ctr"/>
+          <a:lstStyle/>
+          <a:p>
+            <a:pPr indent="0" marL="0">
+              <a:buNone/>
+            </a:pPr>
+            <a:r>
+              <a:rPr lang="en-US" sz="1250" dirty="0">
                 <a:solidFill>
                   <a:srgbClr val="F2F7F5"/>
                 </a:solidFill>
@@ -7244,401 +7285,54 @@
                 <a:ea typeface="Calibri" pitchFamily="34" charset="-122"/>
                 <a:cs typeface="Calibri" pitchFamily="34" charset="-120"/>
               </a:rPr>
-              <a:t>Businesses: listing fee + share-register subscription</a:t>
-            </a:r>
-            <a:endParaRPr lang="en-US" sz="1350" dirty="0"/>
-          </a:p>
-        </p:txBody>
-      </p:sp>
-      <p:sp>
-        <p:nvSpPr>
-          <p:cNvPr id="20" name="Shape 18"/>
-          <p:cNvSpPr/>
-          <p:nvPr/>
-        </p:nvSpPr>
-        <p:spPr>
-          <a:xfrm>
-            <a:off x="731520" y="4361688"/>
-            <a:ext cx="146304" cy="146304"/>
-          </a:xfrm>
-          <a:prstGeom prst="ellipse">
-            <a:avLst/>
-          </a:prstGeom>
-          <a:solidFill>
-            <a:srgbClr val="E3A83A"/>
-          </a:solidFill>
-          <a:ln w="12700">
-            <a:solidFill>
-              <a:srgbClr val="E3A83A"/>
-            </a:solidFill>
-            <a:prstDash val="solid"/>
-          </a:ln>
-        </p:spPr>
-      </p:sp>
-      <p:sp>
-        <p:nvSpPr>
-          <p:cNvPr id="21" name="Text 19"/>
-          <p:cNvSpPr txBox="1"/>
-          <p:nvPr/>
-        </p:nvSpPr>
-        <p:spPr>
-          <a:xfrm>
-            <a:off x="1024128" y="4270248"/>
-            <a:ext cx="2953512" cy="640080"/>
-          </a:xfrm>
-          <a:prstGeom prst="rect">
-            <a:avLst/>
-          </a:prstGeom>
-          <a:noFill/>
-          <a:ln/>
-        </p:spPr>
-        <p:txBody>
-          <a:bodyPr wrap="square" lIns="0" tIns="0" rIns="0" bIns="0" rtlCol="0" anchor="t"/>
-          <a:lstStyle/>
-          <a:p>
-            <a:pPr indent="0" marL="0">
-              <a:buNone/>
-            </a:pPr>
-            <a:r>
-              <a:rPr lang="en-US" sz="1350" dirty="0">
-                <a:solidFill>
-                  <a:srgbClr val="F2F7F5"/>
+              <a:t>Custody, offerings and transfer services, so investors keep their rights and their proof.</a:t>
+            </a:r>
+            <a:endParaRPr lang="en-US" sz="1250" dirty="0"/>
+          </a:p>
+        </p:txBody>
+      </p:sp>
+      <p:sp>
+        <p:nvSpPr>
+          <p:cNvPr id="22" name="Text 20"/>
+          <p:cNvSpPr txBox="1"/>
+          <p:nvPr/>
+        </p:nvSpPr>
+        <p:spPr>
+          <a:xfrm>
+            <a:off x="502920" y="6199632"/>
+            <a:ext cx="7269480" cy="274320"/>
+          </a:xfrm>
+          <a:prstGeom prst="rect">
+            <a:avLst/>
+          </a:prstGeom>
+          <a:noFill/>
+          <a:ln/>
+        </p:spPr>
+        <p:txBody>
+          <a:bodyPr wrap="square" lIns="0" tIns="0" rIns="0" bIns="0" rtlCol="0" anchor="ctr"/>
+          <a:lstStyle/>
+          <a:p>
+            <a:pPr indent="0" marL="0">
+              <a:buNone/>
+            </a:pPr>
+            <a:r>
+              <a:rPr lang="en-US" sz="1100" dirty="0">
+                <a:solidFill>
+                  <a:srgbClr val="7E948F"/>
                 </a:solidFill>
                 <a:latin typeface="Calibri" pitchFamily="34" charset="0"/>
                 <a:ea typeface="Calibri" pitchFamily="34" charset="-122"/>
                 <a:cs typeface="Calibri" pitchFamily="34" charset="-120"/>
               </a:rPr>
-              <a:t>Per share transfer fee</a:t>
-            </a:r>
-            <a:endParaRPr lang="en-US" sz="1350" dirty="0"/>
-          </a:p>
-        </p:txBody>
-      </p:sp>
-      <p:sp>
-        <p:nvSpPr>
-          <p:cNvPr id="22" name="Shape 20"/>
-          <p:cNvSpPr/>
-          <p:nvPr/>
-        </p:nvSpPr>
-        <p:spPr>
-          <a:xfrm>
-            <a:off x="731520" y="5020056"/>
-            <a:ext cx="146304" cy="146304"/>
-          </a:xfrm>
-          <a:prstGeom prst="ellipse">
-            <a:avLst/>
-          </a:prstGeom>
-          <a:solidFill>
-            <a:srgbClr val="E3A83A"/>
-          </a:solidFill>
-          <a:ln w="12700">
-            <a:solidFill>
-              <a:srgbClr val="E3A83A"/>
-            </a:solidFill>
-            <a:prstDash val="solid"/>
-          </a:ln>
-        </p:spPr>
-      </p:sp>
-      <p:sp>
-        <p:nvSpPr>
-          <p:cNvPr id="23" name="Text 21"/>
-          <p:cNvSpPr txBox="1"/>
-          <p:nvPr/>
-        </p:nvSpPr>
-        <p:spPr>
-          <a:xfrm>
-            <a:off x="1024128" y="4928616"/>
-            <a:ext cx="2953512" cy="640080"/>
-          </a:xfrm>
-          <a:prstGeom prst="rect">
-            <a:avLst/>
-          </a:prstGeom>
-          <a:noFill/>
-          <a:ln/>
-        </p:spPr>
-        <p:txBody>
-          <a:bodyPr wrap="square" lIns="0" tIns="0" rIns="0" bIns="0" rtlCol="0" anchor="t"/>
-          <a:lstStyle/>
-          <a:p>
-            <a:pPr indent="0" marL="0">
-              <a:buNone/>
-            </a:pPr>
-            <a:r>
-              <a:rPr lang="en-US" sz="1350" dirty="0">
-                <a:solidFill>
-                  <a:srgbClr val="F2F7F5"/>
-                </a:solidFill>
-                <a:latin typeface="Calibri" pitchFamily="34" charset="0"/>
-                <a:ea typeface="Calibri" pitchFamily="34" charset="-122"/>
-                <a:cs typeface="Calibri" pitchFamily="34" charset="-120"/>
-              </a:rPr>
-              <a:t>0.5–1% of each dividend round</a:t>
-            </a:r>
-            <a:endParaRPr lang="en-US" sz="1350" dirty="0"/>
-          </a:p>
-        </p:txBody>
-      </p:sp>
-      <p:sp>
-        <p:nvSpPr>
-          <p:cNvPr id="24" name="Shape 22"/>
-          <p:cNvSpPr/>
-          <p:nvPr/>
-        </p:nvSpPr>
-        <p:spPr>
-          <a:xfrm>
-            <a:off x="4251960" y="3108960"/>
-            <a:ext cx="3520440" cy="3063240"/>
-          </a:xfrm>
-          <a:prstGeom prst="roundRect">
-            <a:avLst>
-              <a:gd name="adj" fmla="val 3582"/>
-            </a:avLst>
-          </a:prstGeom>
-          <a:solidFill>
-            <a:srgbClr val="12201D"/>
-          </a:solidFill>
-          <a:ln w="12700">
-            <a:solidFill>
-              <a:srgbClr val="25403A"/>
-            </a:solidFill>
-            <a:prstDash val="solid"/>
-          </a:ln>
-        </p:spPr>
-      </p:sp>
-      <p:sp>
-        <p:nvSpPr>
-          <p:cNvPr id="25" name="Text 23"/>
-          <p:cNvSpPr txBox="1"/>
-          <p:nvPr/>
-        </p:nvSpPr>
-        <p:spPr>
-          <a:xfrm>
-            <a:off x="4480560" y="3246120"/>
-            <a:ext cx="3200400" cy="274320"/>
-          </a:xfrm>
-          <a:prstGeom prst="rect">
-            <a:avLst/>
-          </a:prstGeom>
-          <a:noFill/>
-          <a:ln/>
-        </p:spPr>
-        <p:txBody>
-          <a:bodyPr wrap="square" lIns="0" tIns="0" rIns="0" bIns="0" rtlCol="0" anchor="ctr"/>
-          <a:lstStyle/>
-          <a:p>
-            <a:pPr indent="0" marL="0">
-              <a:buNone/>
-            </a:pPr>
-            <a:r>
-              <a:rPr lang="en-US" sz="1150" b="1" spc="300" kern="0" dirty="0">
-                <a:solidFill>
-                  <a:srgbClr val="22A07F"/>
-                </a:solidFill>
-                <a:latin typeface="Calibri" pitchFamily="34" charset="0"/>
-                <a:ea typeface="Calibri" pitchFamily="34" charset="-122"/>
-                <a:cs typeface="Calibri" pitchFamily="34" charset="-120"/>
-              </a:rPr>
-              <a:t>WHO IT'S FOR</a:t>
-            </a:r>
-            <a:endParaRPr lang="en-US" sz="1150" dirty="0"/>
-          </a:p>
-        </p:txBody>
-      </p:sp>
-      <p:sp>
-        <p:nvSpPr>
-          <p:cNvPr id="26" name="Shape 24"/>
-          <p:cNvSpPr/>
-          <p:nvPr/>
-        </p:nvSpPr>
-        <p:spPr>
-          <a:xfrm>
-            <a:off x="4480560" y="3703320"/>
-            <a:ext cx="146304" cy="146304"/>
-          </a:xfrm>
-          <a:prstGeom prst="ellipse">
-            <a:avLst/>
-          </a:prstGeom>
-          <a:solidFill>
-            <a:srgbClr val="22A07F"/>
-          </a:solidFill>
-          <a:ln w="12700">
-            <a:solidFill>
-              <a:srgbClr val="22A07F"/>
-            </a:solidFill>
-            <a:prstDash val="solid"/>
-          </a:ln>
-        </p:spPr>
-      </p:sp>
-      <p:sp>
-        <p:nvSpPr>
-          <p:cNvPr id="27" name="Text 25"/>
-          <p:cNvSpPr txBox="1"/>
-          <p:nvPr/>
-        </p:nvSpPr>
-        <p:spPr>
-          <a:xfrm>
-            <a:off x="4773168" y="3611880"/>
-            <a:ext cx="2862072" cy="640080"/>
-          </a:xfrm>
-          <a:prstGeom prst="rect">
-            <a:avLst/>
-          </a:prstGeom>
-          <a:noFill/>
-          <a:ln/>
-        </p:spPr>
-        <p:txBody>
-          <a:bodyPr wrap="square" lIns="0" tIns="0" rIns="0" bIns="0" rtlCol="0" anchor="t"/>
-          <a:lstStyle/>
-          <a:p>
-            <a:pPr indent="0" marL="0">
-              <a:buNone/>
-            </a:pPr>
-            <a:r>
-              <a:rPr lang="en-US" sz="1350" dirty="0">
-                <a:solidFill>
-                  <a:srgbClr val="F2F7F5"/>
-                </a:solidFill>
-                <a:latin typeface="Calibri" pitchFamily="34" charset="0"/>
-                <a:ea typeface="Calibri" pitchFamily="34" charset="-122"/>
-                <a:cs typeface="Calibri" pitchFamily="34" charset="-120"/>
-              </a:rPr>
-              <a:t>Investors, retail and professional</a:t>
-            </a:r>
-            <a:endParaRPr lang="en-US" sz="1350" dirty="0"/>
-          </a:p>
-        </p:txBody>
-      </p:sp>
-      <p:sp>
-        <p:nvSpPr>
-          <p:cNvPr id="28" name="Shape 26"/>
-          <p:cNvSpPr/>
-          <p:nvPr/>
-        </p:nvSpPr>
-        <p:spPr>
-          <a:xfrm>
-            <a:off x="4480560" y="4361688"/>
-            <a:ext cx="146304" cy="146304"/>
-          </a:xfrm>
-          <a:prstGeom prst="ellipse">
-            <a:avLst/>
-          </a:prstGeom>
-          <a:solidFill>
-            <a:srgbClr val="22A07F"/>
-          </a:solidFill>
-          <a:ln w="12700">
-            <a:solidFill>
-              <a:srgbClr val="22A07F"/>
-            </a:solidFill>
-            <a:prstDash val="solid"/>
-          </a:ln>
-        </p:spPr>
-      </p:sp>
-      <p:sp>
-        <p:nvSpPr>
-          <p:cNvPr id="29" name="Text 27"/>
-          <p:cNvSpPr txBox="1"/>
-          <p:nvPr/>
-        </p:nvSpPr>
-        <p:spPr>
-          <a:xfrm>
-            <a:off x="4773168" y="4270248"/>
-            <a:ext cx="2862072" cy="640080"/>
-          </a:xfrm>
-          <a:prstGeom prst="rect">
-            <a:avLst/>
-          </a:prstGeom>
-          <a:noFill/>
-          <a:ln/>
-        </p:spPr>
-        <p:txBody>
-          <a:bodyPr wrap="square" lIns="0" tIns="0" rIns="0" bIns="0" rtlCol="0" anchor="t"/>
-          <a:lstStyle/>
-          <a:p>
-            <a:pPr indent="0" marL="0">
-              <a:buNone/>
-            </a:pPr>
-            <a:r>
-              <a:rPr lang="en-US" sz="1350" dirty="0">
-                <a:solidFill>
-                  <a:srgbClr val="F2F7F5"/>
-                </a:solidFill>
-                <a:latin typeface="Calibri" pitchFamily="34" charset="0"/>
-                <a:ea typeface="Calibri" pitchFamily="34" charset="-122"/>
-                <a:cs typeface="Calibri" pitchFamily="34" charset="-120"/>
-              </a:rPr>
-              <a:t>Businesses raising from them (AU · VN)</a:t>
-            </a:r>
-            <a:endParaRPr lang="en-US" sz="1350" dirty="0"/>
-          </a:p>
-        </p:txBody>
-      </p:sp>
-      <p:sp>
-        <p:nvSpPr>
-          <p:cNvPr id="30" name="Shape 28"/>
-          <p:cNvSpPr/>
-          <p:nvPr/>
-        </p:nvSpPr>
-        <p:spPr>
-          <a:xfrm>
-            <a:off x="4480560" y="5020056"/>
-            <a:ext cx="146304" cy="146304"/>
-          </a:xfrm>
-          <a:prstGeom prst="ellipse">
-            <a:avLst/>
-          </a:prstGeom>
-          <a:solidFill>
-            <a:srgbClr val="22A07F"/>
-          </a:solidFill>
-          <a:ln w="12700">
-            <a:solidFill>
-              <a:srgbClr val="22A07F"/>
-            </a:solidFill>
-            <a:prstDash val="solid"/>
-          </a:ln>
-        </p:spPr>
-      </p:sp>
-      <p:sp>
-        <p:nvSpPr>
-          <p:cNvPr id="31" name="Text 29"/>
-          <p:cNvSpPr txBox="1"/>
-          <p:nvPr/>
-        </p:nvSpPr>
-        <p:spPr>
-          <a:xfrm>
-            <a:off x="4773168" y="4928616"/>
-            <a:ext cx="2862072" cy="640080"/>
-          </a:xfrm>
-          <a:prstGeom prst="rect">
-            <a:avLst/>
-          </a:prstGeom>
-          <a:noFill/>
-          <a:ln/>
-        </p:spPr>
-        <p:txBody>
-          <a:bodyPr wrap="square" lIns="0" tIns="0" rIns="0" bIns="0" rtlCol="0" anchor="t"/>
-          <a:lstStyle/>
-          <a:p>
-            <a:pPr indent="0" marL="0">
-              <a:buNone/>
-            </a:pPr>
-            <a:r>
-              <a:rPr lang="en-US" sz="1350" dirty="0">
-                <a:solidFill>
-                  <a:srgbClr val="F2F7F5"/>
-                </a:solidFill>
-                <a:latin typeface="Calibri" pitchFamily="34" charset="0"/>
-                <a:ea typeface="Calibri" pitchFamily="34" charset="-122"/>
-                <a:cs typeface="Calibri" pitchFamily="34" charset="-120"/>
-              </a:rPr>
-              <a:t>Accelerators, VCs, licensed partners</a:t>
-            </a:r>
-            <a:endParaRPr lang="en-US" sz="1350" dirty="0"/>
-          </a:p>
-        </p:txBody>
-      </p:sp>
-      <p:sp>
-        <p:nvSpPr>
-          <p:cNvPr id="32" name="Shape 30"/>
+              <a:t>Revenue: listing fee · share-register subscription · small transfer and dividend fees</a:t>
+            </a:r>
+            <a:endParaRPr lang="en-US" sz="1100" dirty="0"/>
+          </a:p>
+        </p:txBody>
+      </p:sp>
+      <p:sp>
+        <p:nvSpPr>
+          <p:cNvPr id="23" name="Shape 21"/>
           <p:cNvSpPr/>
           <p:nvPr/>
         </p:nvSpPr>
@@ -7665,7 +7359,7 @@
       </p:sp>
       <p:pic>
         <p:nvPicPr>
-          <p:cNvPr id="33" name="Image 0" descr="img/founder-qr.jpg">    </p:cNvPr>
+          <p:cNvPr id="24" name="Image 0" descr="img/founder-qr.jpg">    </p:cNvPr>
           <p:cNvPicPr>
             <a:picLocks noChangeAspect="1"/>
           </p:cNvPicPr>
@@ -7689,7 +7383,7 @@
       </p:pic>
       <p:sp>
         <p:nvSpPr>
-          <p:cNvPr id="34" name="Text 31"/>
+          <p:cNvPr id="25" name="Text 22"/>
           <p:cNvSpPr txBox="1"/>
           <p:nvPr/>
         </p:nvSpPr>
@@ -7728,7 +7422,7 @@
       </p:sp>
       <p:pic>
         <p:nvPicPr>
-          <p:cNvPr id="35" name="Image 1" descr="preencoded.png">    </p:cNvPr>
+          <p:cNvPr id="26" name="Image 1" descr="preencoded.png">    </p:cNvPr>
           <p:cNvPicPr>
             <a:picLocks noChangeAspect="1"/>
           </p:cNvPicPr>
@@ -7752,7 +7446,7 @@
       </p:pic>
       <p:sp>
         <p:nvSpPr>
-          <p:cNvPr id="36" name="Text 32"/>
+          <p:cNvPr id="27" name="Text 23"/>
           <p:cNvSpPr txBox="1"/>
           <p:nvPr/>
         </p:nvSpPr>
@@ -7791,7 +7485,7 @@
       </p:sp>
       <p:sp>
         <p:nvSpPr>
-          <p:cNvPr id="37" name="Text 33"/>
+          <p:cNvPr id="28" name="Text 24"/>
           <p:cNvSpPr txBox="1"/>
           <p:nvPr/>
         </p:nvSpPr>
@@ -7830,14 +7524,14 @@
       </p:sp>
       <p:sp>
         <p:nvSpPr>
-          <p:cNvPr id="38" name="Text 34"/>
+          <p:cNvPr id="29" name="Text 25"/>
           <p:cNvSpPr txBox="1"/>
           <p:nvPr/>
         </p:nvSpPr>
         <p:spPr>
           <a:xfrm>
             <a:off x="8183880" y="4315968"/>
-            <a:ext cx="3291840" cy="320040"/>
+            <a:ext cx="3291840" cy="640080"/>
           </a:xfrm>
           <a:prstGeom prst="rect">
             <a:avLst/>
@@ -7861,7 +7555,7 @@
                 <a:ea typeface="Arial" pitchFamily="34" charset="-122"/>
                 <a:cs typeface="Arial" pitchFamily="34" charset="-120"/>
               </a:rPr>
-              <a:t>We're looking for</a:t>
+              <a:t>Know the business you invest in.</a:t>
             </a:r>
             <a:endParaRPr lang="en-US" sz="1600" dirty="0"/>
           </a:p>
@@ -7869,14 +7563,14 @@
       </p:sp>
       <p:sp>
         <p:nvSpPr>
-          <p:cNvPr id="39" name="Text 35"/>
-          <p:cNvSpPr txBox="1"/>
-          <p:nvPr/>
-        </p:nvSpPr>
-        <p:spPr>
-          <a:xfrm>
-            <a:off x="8183880" y="4636008"/>
-            <a:ext cx="3291840" cy="640080"/>
+          <p:cNvPr id="30" name="Text 26"/>
+          <p:cNvSpPr txBox="1"/>
+          <p:nvPr/>
+        </p:nvSpPr>
+        <p:spPr>
+          <a:xfrm>
+            <a:off x="8183880" y="5029200"/>
+            <a:ext cx="3291840" cy="320040"/>
           </a:xfrm>
           <a:prstGeom prst="rect">
             <a:avLst/>
@@ -7892,29 +7586,29 @@
               <a:buNone/>
             </a:pPr>
             <a:r>
-              <a:rPr lang="en-US" sz="1350" dirty="0">
-                <a:solidFill>
-                  <a:srgbClr val="F2F7F5"/>
+              <a:rPr lang="en-US" sz="1300" dirty="0">
+                <a:solidFill>
+                  <a:srgbClr val="A9BDB7"/>
                 </a:solidFill>
                 <a:latin typeface="Calibri" pitchFamily="34" charset="0"/>
                 <a:ea typeface="Calibri" pitchFamily="34" charset="-122"/>
                 <a:cs typeface="Calibri" pitchFamily="34" charset="-120"/>
               </a:rPr>
-              <a:t>Pilot businesses · investor communities · licensed partners</a:t>
-            </a:r>
-            <a:endParaRPr lang="en-US" sz="1350" dirty="0"/>
-          </a:p>
-        </p:txBody>
-      </p:sp>
-      <p:sp>
-        <p:nvSpPr>
-          <p:cNvPr id="40" name="Text 36"/>
-          <p:cNvSpPr txBox="1"/>
-          <p:nvPr/>
-        </p:nvSpPr>
-        <p:spPr>
-          <a:xfrm>
-            <a:off x="8183880" y="5349240"/>
+              <a:t>Long Do · admin@blockid.au</a:t>
+            </a:r>
+            <a:endParaRPr lang="en-US" sz="1300" dirty="0"/>
+          </a:p>
+        </p:txBody>
+      </p:sp>
+      <p:sp>
+        <p:nvSpPr>
+          <p:cNvPr id="31" name="Text 27"/>
+          <p:cNvSpPr txBox="1"/>
+          <p:nvPr/>
+        </p:nvSpPr>
+        <p:spPr>
+          <a:xfrm>
+            <a:off x="8183880" y="5321808"/>
             <a:ext cx="3291840" cy="320040"/>
           </a:xfrm>
           <a:prstGeom prst="rect">
@@ -7931,29 +7625,29 @@
               <a:buNone/>
             </a:pPr>
             <a:r>
-              <a:rPr lang="en-US" sz="1300" dirty="0">
-                <a:solidFill>
-                  <a:srgbClr val="A9BDB7"/>
+              <a:rPr lang="en-US" sz="1150" dirty="0">
+                <a:solidFill>
+                  <a:srgbClr val="7E948F"/>
                 </a:solidFill>
                 <a:latin typeface="Calibri" pitchFamily="34" charset="0"/>
                 <a:ea typeface="Calibri" pitchFamily="34" charset="-122"/>
                 <a:cs typeface="Calibri" pitchFamily="34" charset="-120"/>
               </a:rPr>
-              <a:t>Long Do · admin@blockid.au</a:t>
-            </a:r>
-            <a:endParaRPr lang="en-US" sz="1300" dirty="0"/>
-          </a:p>
-        </p:txBody>
-      </p:sp>
-      <p:sp>
-        <p:nvSpPr>
-          <p:cNvPr id="41" name="Text 37"/>
-          <p:cNvSpPr txBox="1"/>
-          <p:nvPr/>
-        </p:nvSpPr>
-        <p:spPr>
-          <a:xfrm>
-            <a:off x="8183880" y="5641848"/>
+              <a:t>linkedin.com/in/dovanlong</a:t>
+            </a:r>
+            <a:endParaRPr lang="en-US" sz="1150" dirty="0"/>
+          </a:p>
+        </p:txBody>
+      </p:sp>
+      <p:sp>
+        <p:nvSpPr>
+          <p:cNvPr id="32" name="Text 28"/>
+          <p:cNvSpPr txBox="1"/>
+          <p:nvPr/>
+        </p:nvSpPr>
+        <p:spPr>
+          <a:xfrm>
+            <a:off x="8183880" y="5614416"/>
             <a:ext cx="3291840" cy="320040"/>
           </a:xfrm>
           <a:prstGeom prst="rect">
@@ -7972,13 +7666,13 @@
             <a:r>
               <a:rPr lang="en-US" sz="1150" dirty="0">
                 <a:solidFill>
-                  <a:srgbClr val="7E948F"/>
+                  <a:srgbClr val="22A07F"/>
                 </a:solidFill>
                 <a:latin typeface="Calibri" pitchFamily="34" charset="0"/>
                 <a:ea typeface="Calibri" pitchFamily="34" charset="-122"/>
                 <a:cs typeface="Calibri" pitchFamily="34" charset="-120"/>
               </a:rPr>
-              <a:t>linkedin.com/in/dovanlong</a:t>
+              <a:t>eth.blockid.au · hr.blockid.au</a:t>
             </a:r>
             <a:endParaRPr lang="en-US" sz="1150" dirty="0"/>
           </a:p>
@@ -7986,7 +7680,7 @@
       </p:sp>
       <p:sp>
         <p:nvSpPr>
-          <p:cNvPr id="42" name="Text 38"/>
+          <p:cNvPr id="33" name="Text 29"/>
           <p:cNvSpPr txBox="1"/>
           <p:nvPr/>
         </p:nvSpPr>

</xml_diff>